<commit_message>
last update on slides
</commit_message>
<xml_diff>
--- a/08-Presentation/Asmaa-Presentation.pptx
+++ b/08-Presentation/Asmaa-Presentation.pptx
@@ -6,7 +6,7 @@
     <p:sldMasterId id="2147483681" r:id="rId2"/>
   </p:sldMasterIdLst>
   <p:notesMasterIdLst>
-    <p:notesMasterId r:id="rId15"/>
+    <p:notesMasterId r:id="rId16"/>
   </p:notesMasterIdLst>
   <p:sldIdLst>
     <p:sldId id="256" r:id="rId3"/>
@@ -20,29 +20,30 @@
     <p:sldId id="301" r:id="rId11"/>
     <p:sldId id="264" r:id="rId12"/>
     <p:sldId id="267" r:id="rId13"/>
-    <p:sldId id="300" r:id="rId14"/>
+    <p:sldId id="302" r:id="rId14"/>
+    <p:sldId id="300" r:id="rId15"/>
   </p:sldIdLst>
   <p:sldSz cx="9144000" cy="5143500" type="screen16x9"/>
   <p:notesSz cx="6858000" cy="9144000"/>
   <p:embeddedFontLst>
     <p:embeddedFont>
       <p:font typeface="Anaheim" panose="020B0604020202020204" charset="0"/>
-      <p:regular r:id="rId16"/>
-      <p:bold r:id="rId17"/>
+      <p:regular r:id="rId17"/>
+      <p:bold r:id="rId18"/>
     </p:embeddedFont>
     <p:embeddedFont>
       <p:font typeface="Poppins" panose="00000500000000000000" pitchFamily="2" charset="0"/>
-      <p:regular r:id="rId18"/>
-      <p:bold r:id="rId19"/>
-      <p:italic r:id="rId20"/>
-      <p:boldItalic r:id="rId21"/>
+      <p:regular r:id="rId19"/>
+      <p:bold r:id="rId20"/>
+      <p:italic r:id="rId21"/>
+      <p:boldItalic r:id="rId22"/>
     </p:embeddedFont>
     <p:embeddedFont>
       <p:font typeface="Roboto Medium" panose="02000000000000000000" pitchFamily="2" charset="0"/>
-      <p:regular r:id="rId22"/>
-      <p:bold r:id="rId23"/>
-      <p:italic r:id="rId24"/>
-      <p:boldItalic r:id="rId25"/>
+      <p:regular r:id="rId23"/>
+      <p:bold r:id="rId24"/>
+      <p:italic r:id="rId25"/>
+      <p:boldItalic r:id="rId26"/>
     </p:embeddedFont>
   </p:embeddedFontLst>
   <p:defaultTextStyle>
@@ -287,6 +288,7 @@
     <p1510:client id="{8E97466D-3B20-41AB-A7A5-32CC200ADA1A}" v="50" dt="2026-02-08T16:27:15.034"/>
     <p1510:client id="{9D5B01E1-8ADC-42D0-9476-AE4CCBBBF1A5}" v="175" dt="2026-02-08T18:53:19.072"/>
     <p1510:client id="{B81DE52B-ACF1-442C-886F-C7E1C99D8B9B}" v="275" dt="2026-02-08T19:52:51.732"/>
+    <p1510:client id="{C3677238-7711-467B-A277-C5EC94D00965}" v="26" dt="2026-02-10T06:01:44.454"/>
   </p1510:revLst>
 </p1510:revInfo>
 </file>
@@ -1252,6 +1254,94 @@
 </file>
 
 <file path=ppt/notesSlides/notesSlide12.xml><?xml version="1.0" encoding="utf-8"?>
+<p:notes xmlns:a="http://schemas.openxmlformats.org/drawingml/2006/main" xmlns:r="http://schemas.openxmlformats.org/officeDocument/2006/relationships" xmlns:p="http://schemas.openxmlformats.org/presentationml/2006/main">
+  <p:cSld>
+    <p:spTree>
+      <p:nvGrpSpPr>
+        <p:cNvPr id="1" name=""/>
+        <p:cNvGrpSpPr/>
+        <p:nvPr/>
+      </p:nvGrpSpPr>
+      <p:grpSpPr>
+        <a:xfrm>
+          <a:off x="0" y="0"/>
+          <a:ext cx="0" cy="0"/>
+          <a:chOff x="0" y="0"/>
+          <a:chExt cx="0" cy="0"/>
+        </a:xfrm>
+      </p:grpSpPr>
+      <p:sp>
+        <p:nvSpPr>
+          <p:cNvPr id="2" name="Slide Image Placeholder 1"/>
+          <p:cNvSpPr>
+            <a:spLocks noGrp="1" noRot="1" noChangeAspect="1"/>
+          </p:cNvSpPr>
+          <p:nvPr>
+            <p:ph type="sldImg"/>
+          </p:nvPr>
+        </p:nvSpPr>
+        <p:spPr/>
+      </p:sp>
+      <p:sp>
+        <p:nvSpPr>
+          <p:cNvPr id="3" name="Notes Placeholder 2"/>
+          <p:cNvSpPr>
+            <a:spLocks noGrp="1"/>
+          </p:cNvSpPr>
+          <p:nvPr>
+            <p:ph type="body" idx="1"/>
+          </p:nvPr>
+        </p:nvSpPr>
+        <p:spPr/>
+        <p:txBody>
+          <a:bodyPr/>
+          <a:lstStyle/>
+          <a:p>
+            <a:pPr marL="285750" indent="-285750">
+              <a:buChar char="•"/>
+            </a:pPr>
+            <a:r>
+              <a:rPr lang="en-US" b="1"/>
+              <a:t>GitHub was used for version control and project collaboration</a:t>
+            </a:r>
+            <a:endParaRPr lang="en-US"/>
+          </a:p>
+          <a:p>
+            <a:pPr marL="285750" indent="-285750">
+              <a:buChar char="•"/>
+            </a:pPr>
+            <a:r>
+              <a:rPr lang="en-US" b="1"/>
+              <a:t>CI/CD workflow was implemented using GitHub Actions</a:t>
+            </a:r>
+            <a:endParaRPr lang="en-US"/>
+          </a:p>
+          <a:p>
+            <a:pPr marL="171450" indent="-171450"/>
+            <a:r>
+              <a:rPr lang="en-US" b="1" dirty="0"/>
+              <a:t>Automation flow for Selenium, K6 and Postman </a:t>
+            </a:r>
+            <a:endParaRPr lang="en-US" dirty="0">
+              <a:ea typeface="Calibri"/>
+            </a:endParaRPr>
+          </a:p>
+        </p:txBody>
+      </p:sp>
+    </p:spTree>
+    <p:extLst>
+      <p:ext uri="{BB962C8B-B14F-4D97-AF65-F5344CB8AC3E}">
+        <p14:creationId xmlns:p14="http://schemas.microsoft.com/office/powerpoint/2010/main" val="3766884515"/>
+      </p:ext>
+    </p:extLst>
+  </p:cSld>
+  <p:clrMapOvr>
+    <a:masterClrMapping/>
+  </p:clrMapOvr>
+</p:notes>
+</file>
+
+<file path=ppt/notesSlides/notesSlide13.xml><?xml version="1.0" encoding="utf-8"?>
 <p:notes xmlns:a="http://schemas.openxmlformats.org/drawingml/2006/main" xmlns:r="http://schemas.openxmlformats.org/officeDocument/2006/relationships" xmlns:p="http://schemas.openxmlformats.org/presentationml/2006/main" showMasterSp="0" showMasterPhAnim="0">
   <p:cSld>
     <p:spTree>
@@ -25054,6 +25144,162 @@
 </file>
 
 <file path=ppt/slides/slide12.xml><?xml version="1.0" encoding="utf-8"?>
+<p:sld xmlns:a="http://schemas.openxmlformats.org/drawingml/2006/main" xmlns:r="http://schemas.openxmlformats.org/officeDocument/2006/relationships" xmlns:p="http://schemas.openxmlformats.org/presentationml/2006/main">
+  <p:cSld>
+    <p:spTree>
+      <p:nvGrpSpPr>
+        <p:cNvPr id="1" name=""/>
+        <p:cNvGrpSpPr/>
+        <p:nvPr/>
+      </p:nvGrpSpPr>
+      <p:grpSpPr>
+        <a:xfrm>
+          <a:off x="0" y="0"/>
+          <a:ext cx="0" cy="0"/>
+          <a:chOff x="0" y="0"/>
+          <a:chExt cx="0" cy="0"/>
+        </a:xfrm>
+      </p:grpSpPr>
+      <p:sp>
+        <p:nvSpPr>
+          <p:cNvPr id="2" name="Title 1">
+            <a:extLst>
+              <a:ext uri="{FF2B5EF4-FFF2-40B4-BE49-F238E27FC236}">
+                <a16:creationId xmlns:a16="http://schemas.microsoft.com/office/drawing/2014/main" id="{AD48FC8E-5EC0-99C5-B130-C46985456140}"/>
+              </a:ext>
+            </a:extLst>
+          </p:cNvPr>
+          <p:cNvSpPr>
+            <a:spLocks noGrp="1"/>
+          </p:cNvSpPr>
+          <p:nvPr>
+            <p:ph type="title"/>
+          </p:nvPr>
+        </p:nvSpPr>
+        <p:spPr>
+          <a:xfrm>
+            <a:off x="2359068" y="244066"/>
+            <a:ext cx="4191000" cy="1043700"/>
+          </a:xfrm>
+        </p:spPr>
+        <p:txBody>
+          <a:bodyPr/>
+          <a:lstStyle/>
+          <a:p>
+            <a:r>
+              <a:rPr lang="en-US" sz="3600" dirty="0"/>
+              <a:t>GITHUB</a:t>
+            </a:r>
+          </a:p>
+        </p:txBody>
+      </p:sp>
+      <p:sp>
+        <p:nvSpPr>
+          <p:cNvPr id="3" name="Subtitle 2">
+            <a:extLst>
+              <a:ext uri="{FF2B5EF4-FFF2-40B4-BE49-F238E27FC236}">
+                <a16:creationId xmlns:a16="http://schemas.microsoft.com/office/drawing/2014/main" id="{A67D92A0-E6A9-3D18-0AEB-0C3B3C28D896}"/>
+              </a:ext>
+            </a:extLst>
+          </p:cNvPr>
+          <p:cNvSpPr>
+            <a:spLocks noGrp="1"/>
+          </p:cNvSpPr>
+          <p:nvPr>
+            <p:ph type="subTitle" idx="1"/>
+          </p:nvPr>
+        </p:nvSpPr>
+        <p:spPr>
+          <a:xfrm>
+            <a:off x="2359068" y="1282025"/>
+            <a:ext cx="4191000" cy="431100"/>
+          </a:xfrm>
+        </p:spPr>
+        <p:txBody>
+          <a:bodyPr/>
+          <a:lstStyle/>
+          <a:p>
+            <a:r>
+              <a:rPr lang="en-US" dirty="0"/>
+              <a:t>CI/CD</a:t>
+            </a:r>
+          </a:p>
+        </p:txBody>
+      </p:sp>
+      <p:pic>
+        <p:nvPicPr>
+          <p:cNvPr id="4" name="Picture 3" descr="A screenshot of a computer program&#10;&#10;AI-generated content may be incorrect.">
+            <a:extLst>
+              <a:ext uri="{FF2B5EF4-FFF2-40B4-BE49-F238E27FC236}">
+                <a16:creationId xmlns:a16="http://schemas.microsoft.com/office/drawing/2014/main" id="{16E66683-FA23-A7C7-A48F-A84AA220EBD3}"/>
+              </a:ext>
+            </a:extLst>
+          </p:cNvPr>
+          <p:cNvPicPr>
+            <a:picLocks noChangeAspect="1"/>
+          </p:cNvPicPr>
+          <p:nvPr/>
+        </p:nvPicPr>
+        <p:blipFill>
+          <a:blip r:embed="rId3"/>
+          <a:stretch>
+            <a:fillRect/>
+          </a:stretch>
+        </p:blipFill>
+        <p:spPr>
+          <a:xfrm>
+            <a:off x="5911112" y="2843604"/>
+            <a:ext cx="2457450" cy="771525"/>
+          </a:xfrm>
+          <a:prstGeom prst="rect">
+            <a:avLst/>
+          </a:prstGeom>
+        </p:spPr>
+      </p:pic>
+      <p:pic>
+        <p:nvPicPr>
+          <p:cNvPr id="5" name="Picture 4" descr="A screenshot of a computer program&#10;&#10;AI-generated content may be incorrect.">
+            <a:extLst>
+              <a:ext uri="{FF2B5EF4-FFF2-40B4-BE49-F238E27FC236}">
+                <a16:creationId xmlns:a16="http://schemas.microsoft.com/office/drawing/2014/main" id="{DB36F2B8-6B55-B86F-AA39-9774E39ED319}"/>
+              </a:ext>
+            </a:extLst>
+          </p:cNvPr>
+          <p:cNvPicPr>
+            <a:picLocks noChangeAspect="1"/>
+          </p:cNvPicPr>
+          <p:nvPr/>
+        </p:nvPicPr>
+        <p:blipFill>
+          <a:blip r:embed="rId4"/>
+          <a:stretch>
+            <a:fillRect/>
+          </a:stretch>
+        </p:blipFill>
+        <p:spPr>
+          <a:xfrm>
+            <a:off x="543186" y="1883276"/>
+            <a:ext cx="5121580" cy="2700403"/>
+          </a:xfrm>
+          <a:prstGeom prst="rect">
+            <a:avLst/>
+          </a:prstGeom>
+        </p:spPr>
+      </p:pic>
+    </p:spTree>
+    <p:extLst>
+      <p:ext uri="{BB962C8B-B14F-4D97-AF65-F5344CB8AC3E}">
+        <p14:creationId xmlns:p14="http://schemas.microsoft.com/office/powerpoint/2010/main" val="3584875142"/>
+      </p:ext>
+    </p:extLst>
+  </p:cSld>
+  <p:clrMapOvr>
+    <a:masterClrMapping/>
+  </p:clrMapOvr>
+</p:sld>
+</file>
+
+<file path=ppt/slides/slide13.xml><?xml version="1.0" encoding="utf-8"?>
 <p:sld xmlns:a="http://schemas.openxmlformats.org/drawingml/2006/main" xmlns:r="http://schemas.openxmlformats.org/officeDocument/2006/relationships" xmlns:p="http://schemas.openxmlformats.org/presentationml/2006/main">
   <p:cSld>
     <p:spTree>

</xml_diff>